<commit_message>
Simplify Labs 1-5 to lab-sized documents and add submission PDFs
- SRS trimmed to 6 use cases with UC3 and UC4 described in full
- Sequence, collaboration and VOPC diagrams limited to those two use cases
- Vision and architecture documents shortened; business rules renumbered
- Removed the alternate-flows sequence diagram, the UC1 analysis diagrams
  and the deployment diagram
- Added tools/md_to_pdf.py and generated submission PDFs for Labs 1-5
- Added SUBMISSION.md describing what to upload for each lab

Co-Authored-By: Claude Opus 5 <noreply@anthropic.com>
</commit_message>
<xml_diff>
--- a/presentation/eRegistrar_Requirements_Design.pptx
+++ b/presentation/eRegistrar_Requirements_Design.pptx
@@ -2870,7 +2870,7 @@
                 <a:ea typeface="Calibri" pitchFamily="34" charset="-122"/>
                 <a:cs typeface="Calibri" pitchFamily="34" charset="-120"/>
               </a:rPr>
-              <a:t>11 use cases, 4 described in full, 12 NFRs</a:t>
+              <a:t>6 use cases, 2 described in full, 6 NFRs</a:t>
             </a:r>
             <a:endParaRPr lang="en-US" sz="1050" dirty="0"/>
           </a:p>
@@ -5536,7 +5536,7 @@
                 <a:ea typeface="Calibri" pitchFamily="34" charset="-122"/>
                 <a:cs typeface="Calibri" pitchFamily="34" charset="-120"/>
               </a:rPr>
-              <a:t>F9</a:t>
+              <a:t>F8</a:t>
             </a:r>
             <a:endParaRPr lang="en-US" sz="1300" dirty="0"/>
           </a:p>
@@ -5656,7 +5656,7 @@
                 <a:ea typeface="Calibri" pitchFamily="34" charset="-122"/>
                 <a:cs typeface="Calibri" pitchFamily="34" charset="-120"/>
               </a:rPr>
-              <a:t>Ten features in total; these six are the ones the architecture has to satisfy.</a:t>
+              <a:t>Eight features in total; these six are the ones the architecture has to satisfy.</a:t>
             </a:r>
             <a:endParaRPr lang="en-US" sz="1200" dirty="0"/>
           </a:p>
@@ -6393,7 +6393,7 @@
                 <a:ea typeface="Calibri" pitchFamily="34" charset="-122"/>
                 <a:cs typeface="Calibri" pitchFamily="34" charset="-120"/>
               </a:rPr>
-              <a:t>11 use cases identified. UC1, UC3, UC4 and UC6 are described in full and carried into analysis.</a:t>
+              <a:t>6 use cases identified. UC3 and UC4 are described in full and carried into analysis.</a:t>
             </a:r>
             <a:endParaRPr lang="en-US" sz="1200" dirty="0"/>
           </a:p>
@@ -6464,7 +6464,7 @@
                 <a:ea typeface="Cambria" pitchFamily="34" charset="-122"/>
                 <a:cs typeface="Cambria" pitchFamily="34" charset="-120"/>
               </a:rPr>
-              <a:t>UC6 — Register for Course</a:t>
+              <a:t>UC4 — Register for Course</a:t>
             </a:r>
             <a:endParaRPr lang="en-US" sz="3400" dirty="0"/>
           </a:p>
@@ -7098,7 +7098,7 @@
                 <a:ea typeface="Calibri" pitchFamily="34" charset="-122"/>
                 <a:cs typeface="Calibri" pitchFamily="34" charset="-120"/>
               </a:rPr>
-              <a:t>Rules enforced (BR11–BR15)</a:t>
+              <a:t>Rules enforced (BR6–BR9)</a:t>
             </a:r>
             <a:endParaRPr lang="en-US" sz="1500" dirty="0"/>
           </a:p>
@@ -7226,27 +7226,6 @@
                 <a:cs typeface="Calibri" pitchFamily="34" charset="-120"/>
               </a:rPr>
               <a:t>No duplicate registration for the course</a:t>
-            </a:r>
-            <a:endParaRPr lang="en-US" sz="1300" dirty="0"/>
-          </a:p>
-          <a:p>
-            <a:pPr marL="342900" indent="-342900">
-              <a:spcAft>
-                <a:spcPts val="700"/>
-              </a:spcAft>
-              <a:buSzPct val="100000"/>
-              <a:buChar char="•"/>
-            </a:pPr>
-            <a:r>
-              <a:rPr lang="en-US" sz="1300" dirty="0">
-                <a:solidFill>
-                  <a:srgbClr val="1F2933"/>
-                </a:solidFill>
-                <a:latin typeface="Calibri" pitchFamily="34" charset="0"/>
-                <a:ea typeface="Calibri" pitchFamily="34" charset="-122"/>
-                <a:cs typeface="Calibri" pitchFamily="34" charset="-120"/>
-              </a:rPr>
-              <a:t>Registration window open (registrar may override, recorded)</a:t>
             </a:r>
             <a:endParaRPr lang="en-US" sz="1300" dirty="0"/>
           </a:p>
@@ -7436,7 +7415,7 @@
         </p:nvSpPr>
         <p:spPr>
           <a:xfrm>
-            <a:off x="548640" y="1371600"/>
+            <a:off x="548640" y="1600200"/>
             <a:ext cx="11064240" cy="1024128"/>
           </a:xfrm>
           <a:prstGeom prst="roundRect">
@@ -7463,7 +7442,7 @@
         </p:nvSpPr>
         <p:spPr>
           <a:xfrm>
-            <a:off x="822960" y="1517904"/>
+            <a:off x="822960" y="1746504"/>
             <a:ext cx="3383280" cy="320040"/>
           </a:xfrm>
           <a:prstGeom prst="rect">
@@ -7488,7 +7467,7 @@
                 <a:ea typeface="Calibri" pitchFamily="34" charset="-122"/>
                 <a:cs typeface="Calibri" pitchFamily="34" charset="-120"/>
               </a:rPr>
-              <a:t>Two-tier client/server</a:t>
+              <a:t>Monolithic single layer</a:t>
             </a:r>
             <a:endParaRPr lang="en-US" sz="1500" dirty="0"/>
           </a:p>
@@ -7502,7 +7481,7 @@
         </p:nvSpPr>
         <p:spPr>
           <a:xfrm>
-            <a:off x="822960" y="1883664"/>
+            <a:off x="822960" y="2112264"/>
             <a:ext cx="3383280" cy="292608"/>
           </a:xfrm>
           <a:prstGeom prst="rect">
@@ -7541,7 +7520,7 @@
         </p:nvSpPr>
         <p:spPr>
           <a:xfrm>
-            <a:off x="4480560" y="1645920"/>
+            <a:off x="4480560" y="1874520"/>
             <a:ext cx="6858000" cy="548640"/>
           </a:xfrm>
           <a:prstGeom prst="rect">
@@ -7566,7 +7545,7 @@
                 <a:ea typeface="Calibri" pitchFamily="34" charset="-122"/>
                 <a:cs typeface="Calibri" pitchFamily="34" charset="-120"/>
               </a:rPr>
-              <a:t>Installed client and DB credentials on the desktop</a:t>
+              <a:t>Volatile scheduling rules scattered through the page code</a:t>
             </a:r>
             <a:endParaRPr lang="en-US" sz="1300" dirty="0"/>
           </a:p>
@@ -7580,7 +7559,7 @@
         </p:nvSpPr>
         <p:spPr>
           <a:xfrm>
-            <a:off x="548640" y="2505456"/>
+            <a:off x="548640" y="2734056"/>
             <a:ext cx="11064240" cy="1024128"/>
           </a:xfrm>
           <a:prstGeom prst="roundRect">
@@ -7607,7 +7586,7 @@
         </p:nvSpPr>
         <p:spPr>
           <a:xfrm>
-            <a:off x="822960" y="2651760"/>
+            <a:off x="822960" y="2880360"/>
             <a:ext cx="3383280" cy="320040"/>
           </a:xfrm>
           <a:prstGeom prst="rect">
@@ -7632,7 +7611,7 @@
                 <a:ea typeface="Calibri" pitchFamily="34" charset="-122"/>
                 <a:cs typeface="Calibri" pitchFamily="34" charset="-120"/>
               </a:rPr>
-              <a:t>Monolithic single layer</a:t>
+              <a:t>Microservices</a:t>
             </a:r>
             <a:endParaRPr lang="en-US" sz="1500" dirty="0"/>
           </a:p>
@@ -7646,7 +7625,7 @@
         </p:nvSpPr>
         <p:spPr>
           <a:xfrm>
-            <a:off x="822960" y="3017520"/>
+            <a:off x="822960" y="3246120"/>
             <a:ext cx="3383280" cy="292608"/>
           </a:xfrm>
           <a:prstGeom prst="rect">
@@ -7685,7 +7664,7 @@
         </p:nvSpPr>
         <p:spPr>
           <a:xfrm>
-            <a:off x="4480560" y="2779776"/>
+            <a:off x="4480560" y="3008376"/>
             <a:ext cx="6858000" cy="548640"/>
           </a:xfrm>
           <a:prstGeom prst="rect">
@@ -7710,7 +7689,7 @@
                 <a:ea typeface="Calibri" pitchFamily="34" charset="-122"/>
                 <a:cs typeface="Calibri" pitchFamily="34" charset="-120"/>
               </a:rPr>
-              <a:t>Volatile scheduling rules scattered through the UI code</a:t>
+              <a:t>Capacity check becomes a distributed transaction; too costly for the team</a:t>
             </a:r>
             <a:endParaRPr lang="en-US" sz="1300" dirty="0"/>
           </a:p>
@@ -7724,151 +7703,7 @@
         </p:nvSpPr>
         <p:spPr>
           <a:xfrm>
-            <a:off x="548640" y="3639312"/>
-            <a:ext cx="11064240" cy="1024128"/>
-          </a:xfrm>
-          <a:prstGeom prst="roundRect">
-            <a:avLst>
-              <a:gd name="adj" fmla="val 7143"/>
-            </a:avLst>
-          </a:prstGeom>
-          <a:solidFill>
-            <a:srgbClr val="F4F8F8"/>
-          </a:solidFill>
-          <a:ln w="12700">
-            <a:solidFill>
-              <a:srgbClr val="E1EAEA"/>
-            </a:solidFill>
-            <a:prstDash val="solid"/>
-          </a:ln>
-        </p:spPr>
-      </p:sp>
-      <p:sp>
-        <p:nvSpPr>
-          <p:cNvPr id="13" name="Text 11"/>
-          <p:cNvSpPr/>
-          <p:nvPr/>
-        </p:nvSpPr>
-        <p:spPr>
-          <a:xfrm>
-            <a:off x="822960" y="3785616"/>
-            <a:ext cx="3383280" cy="320040"/>
-          </a:xfrm>
-          <a:prstGeom prst="rect">
-            <a:avLst/>
-          </a:prstGeom>
-          <a:noFill/>
-          <a:ln/>
-        </p:spPr>
-        <p:txBody>
-          <a:bodyPr wrap="square" lIns="0" tIns="0" rIns="0" bIns="0" rtlCol="0" anchor="ctr"/>
-          <a:lstStyle/>
-          <a:p>
-            <a:pPr indent="0" marL="0">
-              <a:buNone/>
-            </a:pPr>
-            <a:r>
-              <a:rPr lang="en-US" sz="1500" b="1" dirty="0">
-                <a:solidFill>
-                  <a:srgbClr val="1F2933"/>
-                </a:solidFill>
-                <a:latin typeface="Calibri" pitchFamily="34" charset="0"/>
-                <a:ea typeface="Calibri" pitchFamily="34" charset="-122"/>
-                <a:cs typeface="Calibri" pitchFamily="34" charset="-120"/>
-              </a:rPr>
-              <a:t>Microservices</a:t>
-            </a:r>
-            <a:endParaRPr lang="en-US" sz="1500" dirty="0"/>
-          </a:p>
-        </p:txBody>
-      </p:sp>
-      <p:sp>
-        <p:nvSpPr>
-          <p:cNvPr id="14" name="Text 12"/>
-          <p:cNvSpPr/>
-          <p:nvPr/>
-        </p:nvSpPr>
-        <p:spPr>
-          <a:xfrm>
-            <a:off x="822960" y="4151376"/>
-            <a:ext cx="3383280" cy="292608"/>
-          </a:xfrm>
-          <a:prstGeom prst="rect">
-            <a:avLst/>
-          </a:prstGeom>
-          <a:noFill/>
-          <a:ln/>
-        </p:spPr>
-        <p:txBody>
-          <a:bodyPr wrap="square" lIns="0" tIns="0" rIns="0" bIns="0" rtlCol="0" anchor="ctr"/>
-          <a:lstStyle/>
-          <a:p>
-            <a:pPr indent="0" marL="0">
-              <a:buNone/>
-            </a:pPr>
-            <a:r>
-              <a:rPr lang="en-US" sz="1250" b="1" dirty="0">
-                <a:solidFill>
-                  <a:srgbClr val="B8860B"/>
-                </a:solidFill>
-                <a:latin typeface="Calibri" pitchFamily="34" charset="0"/>
-                <a:ea typeface="Calibri" pitchFamily="34" charset="-122"/>
-                <a:cs typeface="Calibri" pitchFamily="34" charset="-120"/>
-              </a:rPr>
-              <a:t>Deferred</a:t>
-            </a:r>
-            <a:endParaRPr lang="en-US" sz="1250" dirty="0"/>
-          </a:p>
-        </p:txBody>
-      </p:sp>
-      <p:sp>
-        <p:nvSpPr>
-          <p:cNvPr id="15" name="Text 13"/>
-          <p:cNvSpPr/>
-          <p:nvPr/>
-        </p:nvSpPr>
-        <p:spPr>
-          <a:xfrm>
-            <a:off x="4480560" y="3913632"/>
-            <a:ext cx="6858000" cy="548640"/>
-          </a:xfrm>
-          <a:prstGeom prst="rect">
-            <a:avLst/>
-          </a:prstGeom>
-          <a:noFill/>
-          <a:ln/>
-        </p:spPr>
-        <p:txBody>
-          <a:bodyPr wrap="square" lIns="0" tIns="0" rIns="0" bIns="0" rtlCol="0" anchor="ctr"/>
-          <a:lstStyle/>
-          <a:p>
-            <a:pPr indent="0" marL="0">
-              <a:buNone/>
-            </a:pPr>
-            <a:r>
-              <a:rPr lang="en-US" sz="1300" dirty="0">
-                <a:solidFill>
-                  <a:srgbClr val="5B6B7C"/>
-                </a:solidFill>
-                <a:latin typeface="Calibri" pitchFamily="34" charset="0"/>
-                <a:ea typeface="Calibri" pitchFamily="34" charset="-122"/>
-                <a:cs typeface="Calibri" pitchFamily="34" charset="-120"/>
-              </a:rPr>
-              <a:t>Distributed transaction across the capacity check; too costly for the team</a:t>
-            </a:r>
-            <a:endParaRPr lang="en-US" sz="1300" dirty="0"/>
-          </a:p>
-        </p:txBody>
-      </p:sp>
-      <p:sp>
-        <p:nvSpPr>
-          <p:cNvPr id="16" name="Shape 14"/>
-          <p:cNvSpPr/>
-          <p:nvPr/>
-        </p:nvSpPr>
-        <p:spPr>
-          <a:xfrm>
-            <a:off x="548640" y="4773168"/>
+            <a:off x="548640" y="3867912"/>
             <a:ext cx="11064240" cy="1024128"/>
           </a:xfrm>
           <a:prstGeom prst="roundRect">
@@ -7889,13 +7724,13 @@
       </p:sp>
       <p:sp>
         <p:nvSpPr>
-          <p:cNvPr id="17" name="Text 15"/>
-          <p:cNvSpPr/>
-          <p:nvPr/>
-        </p:nvSpPr>
-        <p:spPr>
-          <a:xfrm>
-            <a:off x="822960" y="4919472"/>
+          <p:cNvPr id="13" name="Text 11"/>
+          <p:cNvSpPr/>
+          <p:nvPr/>
+        </p:nvSpPr>
+        <p:spPr>
+          <a:xfrm>
+            <a:off x="822960" y="4014216"/>
             <a:ext cx="3383280" cy="320040"/>
           </a:xfrm>
           <a:prstGeom prst="rect">
@@ -7928,13 +7763,13 @@
       </p:sp>
       <p:sp>
         <p:nvSpPr>
-          <p:cNvPr id="18" name="Text 16"/>
-          <p:cNvSpPr/>
-          <p:nvPr/>
-        </p:nvSpPr>
-        <p:spPr>
-          <a:xfrm>
-            <a:off x="822960" y="5285232"/>
+          <p:cNvPr id="14" name="Text 12"/>
+          <p:cNvSpPr/>
+          <p:nvPr/>
+        </p:nvSpPr>
+        <p:spPr>
+          <a:xfrm>
+            <a:off x="822960" y="4379976"/>
             <a:ext cx="3383280" cy="292608"/>
           </a:xfrm>
           <a:prstGeom prst="rect">
@@ -7967,13 +7802,13 @@
       </p:sp>
       <p:sp>
         <p:nvSpPr>
-          <p:cNvPr id="19" name="Text 17"/>
-          <p:cNvSpPr/>
-          <p:nvPr/>
-        </p:nvSpPr>
-        <p:spPr>
-          <a:xfrm>
-            <a:off x="4480560" y="5047488"/>
+          <p:cNvPr id="15" name="Text 13"/>
+          <p:cNvSpPr/>
+          <p:nvPr/>
+        </p:nvSpPr>
+        <p:spPr>
+          <a:xfrm>
+            <a:off x="4480560" y="4142232"/>
             <a:ext cx="6858000" cy="548640"/>
           </a:xfrm>
           <a:prstGeom prst="rect">
@@ -8006,7 +7841,7 @@
       </p:sp>
       <p:sp>
         <p:nvSpPr>
-          <p:cNvPr id="20" name="Text 18"/>
+          <p:cNvPr id="16" name="Text 14"/>
           <p:cNvSpPr/>
           <p:nvPr/>
         </p:nvSpPr>
@@ -8647,7 +8482,7 @@
                 <a:ea typeface="Cambria" pitchFamily="34" charset="-122"/>
                 <a:cs typeface="Cambria" pitchFamily="34" charset="-120"/>
               </a:rPr>
-              <a:t>Use-case realisation — UC6</a:t>
+              <a:t>Use-case realisation — UC4</a:t>
             </a:r>
             <a:endParaRPr lang="en-US" sz="3400" dirty="0"/>
           </a:p>
@@ -8694,7 +8529,7 @@
       </p:sp>
       <p:pic>
         <p:nvPicPr>
-          <p:cNvPr id="4" name="Image 0" descr="/Users/screwby/Projects/CS425/Lab4_SequenceDiagrams/diagrams/sd_uc6_register_for_course.png">    </p:cNvPr>
+          <p:cNvPr id="4" name="Image 0" descr="/Users/screwby/Projects/CS425/Lab4_SequenceDiagrams/diagrams/sd_uc4_register_for_course.png">    </p:cNvPr>
           <p:cNvPicPr>
             <a:picLocks noChangeAspect="1"/>
           </p:cNvPicPr>
@@ -9137,7 +8972,7 @@
       </p:sp>
       <p:pic>
         <p:nvPicPr>
-          <p:cNvPr id="4" name="Image 0" descr="/Users/screwby/Projects/CS425/Lab5_Collaboration_VOPC/diagrams/vopc_uc6_register_for_course.png">    </p:cNvPr>
+          <p:cNvPr id="4" name="Image 0" descr="/Users/screwby/Projects/CS425/Lab5_Collaboration_VOPC/diagrams/vopc_uc4_register_for_course.png">    </p:cNvPr>
           <p:cNvPicPr>
             <a:picLocks noChangeAspect="1"/>
           </p:cNvPicPr>
@@ -9161,7 +8996,7 @@
       </p:pic>
       <p:pic>
         <p:nvPicPr>
-          <p:cNvPr id="5" name="Image 1" descr="/Users/screwby/Projects/CS425/Lab5_Collaboration_VOPC/diagrams/collab_uc6_register_for_course.png">    </p:cNvPr>
+          <p:cNvPr id="5" name="Image 1" descr="/Users/screwby/Projects/CS425/Lab5_Collaboration_VOPC/diagrams/collab_uc4_register_for_course.png">    </p:cNvPr>
           <p:cNvPicPr>
             <a:picLocks noChangeAspect="1"/>
           </p:cNvPicPr>

</xml_diff>

<commit_message>
Clean up prose and punctuation across all docs and code
</commit_message>
<xml_diff>
--- a/presentation/eRegistrar_Requirements_Design.pptx
+++ b/presentation/eRegistrar_Requirements_Design.pptx
@@ -2069,7 +2069,7 @@
                 <a:ea typeface="Calibri" pitchFamily="34" charset="-122"/>
                 <a:cs typeface="Calibri" pitchFamily="34" charset="-120"/>
               </a:rPr>
-              <a:t>Lab 7 — Implementation slice</a:t>
+              <a:t>Lab 7: Implementation slice</a:t>
             </a:r>
             <a:endParaRPr lang="en-US" sz="1200" dirty="0"/>
           </a:p>
@@ -2175,7 +2175,7 @@
                 <a:ea typeface="Calibri" pitchFamily="34" charset="-122"/>
                 <a:cs typeface="Calibri" pitchFamily="34" charset="-120"/>
               </a:rPr>
-              <a:t>Published-schedule view — the read half of UC6</a:t>
+              <a:t>Published-schedule view, the read half of UC4</a:t>
             </a:r>
             <a:endParaRPr lang="en-US" sz="1300" dirty="0"/>
           </a:p>
@@ -3676,7 +3676,7 @@
                 <a:ea typeface="Calibri" pitchFamily="34" charset="-122"/>
                 <a:cs typeface="Calibri" pitchFamily="34" charset="-120"/>
               </a:rPr>
-              <a:t>Lab 1 — Vision</a:t>
+              <a:t>Lab 1: Vision</a:t>
             </a:r>
             <a:endParaRPr lang="en-US" sz="1200" dirty="0"/>
           </a:p>
@@ -4505,7 +4505,7 @@
                 <a:ea typeface="Calibri" pitchFamily="34" charset="-122"/>
                 <a:cs typeface="Calibri" pitchFamily="34" charset="-120"/>
               </a:rPr>
-              <a:t>One system holding courses, faculty profiles, programs and the schedule in a single database — applying the scheduling and prerequisite rules automatically, with role-appropriate web access for administrators, faculty and students.</a:t>
+              <a:t>One system holding courses, faculty profiles, programs and the schedule in a single database, applying the scheduling and prerequisite rules automatically, with role-appropriate web access for administrators, faculty and students.</a:t>
             </a:r>
             <a:endParaRPr lang="en-US" sz="1300" dirty="0"/>
           </a:p>
@@ -4615,7 +4615,7 @@
                 <a:ea typeface="Calibri" pitchFamily="34" charset="-122"/>
                 <a:cs typeface="Calibri" pitchFamily="34" charset="-120"/>
               </a:rPr>
-              <a:t>Lab 1 — Problem / Need / Feature</a:t>
+              <a:t>Lab 1: Problem / Need / Feature</a:t>
             </a:r>
             <a:endParaRPr lang="en-US" sz="1200" dirty="0"/>
           </a:p>
@@ -5116,7 +5116,7 @@
                 <a:ea typeface="Calibri" pitchFamily="34" charset="-122"/>
                 <a:cs typeface="Calibri" pitchFamily="34" charset="-120"/>
               </a:rPr>
-              <a:t>No double-booking, no unqualified assignment — checked, not trusted</a:t>
+              <a:t>No double-booking, no unqualified assignment. Checked, not trusted.</a:t>
             </a:r>
             <a:endParaRPr lang="en-US" sz="1200" dirty="0"/>
           </a:p>
@@ -5766,7 +5766,7 @@
                 <a:ea typeface="Calibri" pitchFamily="34" charset="-122"/>
                 <a:cs typeface="Calibri" pitchFamily="34" charset="-120"/>
               </a:rPr>
-              <a:t>Lab 2 — SRS</a:t>
+              <a:t>Lab 2: SRS</a:t>
             </a:r>
             <a:endParaRPr lang="en-US" sz="1200" dirty="0"/>
           </a:p>
@@ -6464,7 +6464,7 @@
                 <a:ea typeface="Cambria" pitchFamily="34" charset="-122"/>
                 <a:cs typeface="Cambria" pitchFamily="34" charset="-120"/>
               </a:rPr>
-              <a:t>UC4 — Register for Course</a:t>
+              <a:t>UC4: Register for Course</a:t>
             </a:r>
             <a:endParaRPr lang="en-US" sz="3400" dirty="0"/>
           </a:p>
@@ -6503,7 +6503,7 @@
                 <a:ea typeface="Calibri" pitchFamily="34" charset="-122"/>
                 <a:cs typeface="Calibri" pitchFamily="34" charset="-120"/>
               </a:rPr>
-              <a:t>Lab 2 — Use-case description</a:t>
+              <a:t>Lab 2: Use-case description</a:t>
             </a:r>
             <a:endParaRPr lang="en-US" sz="1200" dirty="0"/>
           </a:p>
@@ -7032,7 +7032,7 @@
                 <a:ea typeface="Calibri" pitchFamily="34" charset="-122"/>
                 <a:cs typeface="Calibri" pitchFamily="34" charset="-120"/>
               </a:rPr>
-              <a:t>Registration is created and a seat consumed — in one transaction</a:t>
+              <a:t>Registration is created and a seat consumed, in one transaction</a:t>
             </a:r>
             <a:endParaRPr lang="en-US" sz="1350" dirty="0"/>
           </a:p>
@@ -7401,7 +7401,7 @@
                 <a:ea typeface="Calibri" pitchFamily="34" charset="-122"/>
                 <a:cs typeface="Calibri" pitchFamily="34" charset="-120"/>
               </a:rPr>
-              <a:t>Lab 3 — Architecture</a:t>
+              <a:t>Lab 3: Architecture</a:t>
             </a:r>
             <a:endParaRPr lang="en-US" sz="1200" dirty="0"/>
           </a:p>
@@ -7982,7 +7982,7 @@
                 <a:ea typeface="Calibri" pitchFamily="34" charset="-122"/>
                 <a:cs typeface="Calibri" pitchFamily="34" charset="-120"/>
               </a:rPr>
-              <a:t>Lab 3 — Selected solution</a:t>
+              <a:t>Lab 3: Selected solution</a:t>
             </a:r>
             <a:endParaRPr lang="en-US" sz="1200" dirty="0"/>
           </a:p>
@@ -8249,7 +8249,7 @@
                 <a:ea typeface="Calibri" pitchFamily="34" charset="-122"/>
                 <a:cs typeface="Calibri" pitchFamily="34" charset="-120"/>
               </a:rPr>
-              <a:t>Framework-independent — the invariants live here</a:t>
+              <a:t>Framework-independent, the invariants live here</a:t>
             </a:r>
             <a:endParaRPr lang="en-US" sz="1200" dirty="0"/>
           </a:p>
@@ -8482,7 +8482,7 @@
                 <a:ea typeface="Cambria" pitchFamily="34" charset="-122"/>
                 <a:cs typeface="Cambria" pitchFamily="34" charset="-120"/>
               </a:rPr>
-              <a:t>Use-case realisation — UC4</a:t>
+              <a:t>Use-case realisation: UC4</a:t>
             </a:r>
             <a:endParaRPr lang="en-US" sz="3400" dirty="0"/>
           </a:p>
@@ -8521,7 +8521,7 @@
                 <a:ea typeface="Calibri" pitchFamily="34" charset="-122"/>
                 <a:cs typeface="Calibri" pitchFamily="34" charset="-120"/>
               </a:rPr>
-              <a:t>Lab 4 — Sequence diagram</a:t>
+              <a:t>Lab 4: Sequence diagram</a:t>
             </a:r>
             <a:endParaRPr lang="en-US" sz="1200" dirty="0"/>
           </a:p>
@@ -8854,7 +8854,7 @@
                 <a:ea typeface="Calibri" pitchFamily="34" charset="-122"/>
                 <a:cs typeface="Calibri" pitchFamily="34" charset="-120"/>
               </a:rPr>
-              <a:t>A student who loses the race for the last seat gets "section full" — never an over-filled section.</a:t>
+              <a:t>A student who loses the race for the last seat gets "section full" and never an over-filled section.</a:t>
             </a:r>
             <a:endParaRPr lang="en-US" sz="1250" dirty="0"/>
           </a:p>
@@ -8925,7 +8925,7 @@
                 <a:ea typeface="Cambria" pitchFamily="34" charset="-122"/>
                 <a:cs typeface="Cambria" pitchFamily="34" charset="-120"/>
               </a:rPr>
-              <a:t>Participating classes — VOPC</a:t>
+              <a:t>Participating classes: VOPC</a:t>
             </a:r>
             <a:endParaRPr lang="en-US" sz="3400" dirty="0"/>
           </a:p>
@@ -8964,7 +8964,7 @@
                 <a:ea typeface="Calibri" pitchFamily="34" charset="-122"/>
                 <a:cs typeface="Calibri" pitchFamily="34" charset="-120"/>
               </a:rPr>
-              <a:t>Lab 5 — Collaboration &amp; VOPC</a:t>
+              <a:t>Lab 5: Collaboration &amp; VOPC</a:t>
             </a:r>
             <a:endParaRPr lang="en-US" sz="1200" dirty="0"/>
           </a:p>
@@ -9051,7 +9051,7 @@
                 <a:ea typeface="Calibri" pitchFamily="34" charset="-122"/>
                 <a:cs typeface="Calibri" pitchFamily="34" charset="-120"/>
               </a:rPr>
-              <a:t>VOPC — structure</a:t>
+              <a:t>VOPC structure</a:t>
             </a:r>
             <a:endParaRPr lang="en-US" sz="1200" dirty="0"/>
           </a:p>
@@ -9090,7 +9090,7 @@
                 <a:ea typeface="Calibri" pitchFamily="34" charset="-122"/>
                 <a:cs typeface="Calibri" pitchFamily="34" charset="-120"/>
               </a:rPr>
-              <a:t>Collaboration — the same interaction by object links, numbered 1 … 3.5 … 7</a:t>
+              <a:t>Collaboration: the same interaction by object links, numbered 1, 3.5, 7</a:t>
             </a:r>
             <a:endParaRPr lang="en-US" sz="1200" dirty="0"/>
           </a:p>

</xml_diff>